<commit_message>
merge menu options into synchronized compound actions
</commit_message>
<xml_diff>
--- a/b11402037-b11402053-demo.pptx
+++ b/b11402037-b11402053-demo.pptx
@@ -3803,7 +3803,7 @@
                 <a:latin typeface="Consolas"/>
                 <a:ea typeface="Microsoft JhengHei"/>
               </a:rPr>
-              <a:t>1. 載入 CSV   3. 正規化   5. 匯出</a:t>
+              <a:t>1. 載入   2. 正規化   3. 匯出</a:t>
             </a:r>
           </a:p>
           <a:p>
@@ -9134,7 +9134,7 @@
                 <a:latin typeface="Consolas"/>
                 <a:ea typeface="Microsoft JhengHei"/>
               </a:rPr>
-              <a:t>1 載入 CSV   2 顯示原始   3 執行正規化</a:t>
+              <a:t>1 載入＋顯示原始   2 正規化＋顯示結果</a:t>
             </a:r>
           </a:p>
           <a:p>
@@ -9151,7 +9151,7 @@
                 <a:latin typeface="Consolas"/>
                 <a:ea typeface="Microsoft JhengHei"/>
               </a:rPr>
-              <a:t>4 預覽結果   5 匯出 CSV   0 離開</a:t>
+              <a:t>3 匯出 CSV＋自動離開   0 離開</a:t>
             </a:r>
           </a:p>
           <a:p>
@@ -9168,7 +9168,7 @@
                 <a:latin typeface="Microsoft JhengHei"/>
                 <a:ea typeface="Microsoft JhengHei"/>
               </a:rPr>
-              <a:t>狀態防呆：未載入 / 未正規化時擋下後續操作</a:t>
+              <a:t>同步複合動作設計；狀態防呆擋下未就緒操作</a:t>
             </a:r>
           </a:p>
         </p:txBody>

</xml_diff>